<commit_message>
feat: update settings with new Bash permissions and add presentation files for team
</commit_message>
<xml_diff>
--- a/08_GOBERNANZA/Presentacion ENS equipo optimTech.pptx
+++ b/08_GOBERNANZA/Presentacion ENS equipo optimTech.pptx
@@ -19,6 +19,7 @@
     <p:sldId id="267" r:id="rId13"/>
     <p:sldId id="268" r:id="rId14"/>
     <p:sldId id="269" r:id="rId15"/>
+    <p:sldId id="276" r:id="rId27"/>
     <p:sldId id="270" r:id="rId16"/>
     <p:sldId id="271" r:id="rId17"/>
     <p:sldId id="272" r:id="rId18"/>
@@ -1401,7 +1402,7 @@
           <a:p>
             <a:r>
               <a:rPr lang="en-US" dirty="0"/>
-              <a:t>Recordar que la documentacion viva esta en Confluence (espacio ENSCORP). Para incidentes, contactar al CISO. Para temas de datos personales, al DPO.</a:t>
+              <a:t>El texto completo del RD 311/2022 (ENS) esta disponible en boe.es. Para incidentes, contactar al CISO. Para temas de datos personales, al DPO.</a:t>
             </a:r>
             <a:endParaRPr lang="en-US" dirty="0"/>
           </a:p>
@@ -1612,6 +1613,89 @@
         <p14:creationId xmlns:p14="http://schemas.microsoft.com/office/powerpoint/2010/main" val="1024086991"/>
       </p:ext>
     </p:extLst>
+  </p:cSld>
+  <p:clrMapOvr>
+    <a:masterClrMapping/>
+  </p:clrMapOvr>
+</p:notes>
+</file>
+
+<file path=ppt/notesSlides/notesSlide21.xml><?xml version="1.0" encoding="utf-8"?>
+<p:notes xmlns:a="http://schemas.openxmlformats.org/drawingml/2006/main" xmlns:r="http://schemas.openxmlformats.org/officeDocument/2006/relationships" xmlns:p="http://schemas.openxmlformats.org/presentationml/2006/main">
+  <p:cSld>
+    <p:spTree>
+      <p:nvGrpSpPr>
+        <p:cNvPr id="1" name=""/>
+        <p:cNvGrpSpPr/>
+        <p:nvPr/>
+      </p:nvGrpSpPr>
+      <p:grpSpPr>
+        <a:xfrm>
+          <a:off x="0" y="0"/>
+          <a:ext cx="0" cy="0"/>
+          <a:chOff x="0" y="0"/>
+          <a:chExt cx="0" cy="0"/>
+        </a:xfrm>
+      </p:grpSpPr>
+      <p:sp>
+        <p:nvSpPr>
+          <p:cNvPr id="2" name="Slide Image Placeholder 1"/>
+          <p:cNvSpPr>
+            <a:spLocks noGrp="1" noRot="1" noChangeAspect="1"/>
+          </p:cNvSpPr>
+          <p:nvPr>
+            <p:ph type="sldImg"/>
+          </p:nvPr>
+        </p:nvSpPr>
+        <p:spPr/>
+      </p:sp>
+      <p:sp>
+        <p:nvSpPr>
+          <p:cNvPr id="3" name="Notes Placeholder 2"/>
+          <p:cNvSpPr>
+            <a:spLocks noGrp="1"/>
+          </p:cNvSpPr>
+          <p:nvPr>
+            <p:ph type="body" idx="1"/>
+          </p:nvPr>
+        </p:nvSpPr>
+        <p:spPr/>
+        <p:txBody>
+          <a:bodyPr/>
+          <a:lstStyle/>
+          <a:p>
+            <a:r>
+              <a:rPr lang="en-US" dirty="0"/>
+              <a:t>Marketing va a incorporar herramientas como HubSpot, LinkedIn y plataformas de email marketing. Todas estas herramientas tratan datos personales y requieren actualizar el RAT (D11). Es importante que ANTES de empezar a usar cualquier herramienta nueva, se notifique para evaluar el impacto en proteccion de datos y actualizar la documentacion ENS.</a:t>
+            </a:r>
+            <a:endParaRPr lang="en-US" dirty="0"/>
+          </a:p>
+        </p:txBody>
+      </p:sp>
+      <p:sp>
+        <p:nvSpPr>
+          <p:cNvPr id="4" name="Slide Number Placeholder 3"/>
+          <p:cNvSpPr>
+            <a:spLocks noGrp="1"/>
+          </p:cNvSpPr>
+          <p:nvPr>
+            <p:ph type="sldNum" sz="quarter" idx="10"/>
+          </p:nvPr>
+        </p:nvSpPr>
+        <p:spPr/>
+        <p:txBody>
+          <a:bodyPr/>
+          <a:lstStyle/>
+          <a:p>
+            <a:fld id="{A1B2C3D4-E5F6-7890-ABCD-EF1234567890}" type="slidenum">
+              <a:rPr lang="en-US"/>
+              <a:t>15</a:t>
+            </a:fld>
+            <a:endParaRPr lang="en-US"/>
+          </a:p>
+        </p:txBody>
+      </p:sp>
+    </p:spTree>
   </p:cSld>
   <p:clrMapOvr>
     <a:masterClrMapping/>
@@ -2568,7 +2652,7 @@
       </p:grpSpPr>
       <p:pic>
         <p:nvPicPr>
-          <p:cNvPr id="2" name="Image 0" descr="preencoded.png">    </p:cNvPr>
+          <p:cNvPr id="2" name="Image 0" descr="preencoded.png"/>
           <p:cNvPicPr>
             <a:picLocks noChangeAspect="1"/>
           </p:cNvPicPr>
@@ -2802,7 +2886,7 @@
       </p:sp>
       <p:pic>
         <p:nvPicPr>
-          <p:cNvPr id="4" name="Image 0" descr="preencoded.png">    </p:cNvPr>
+          <p:cNvPr id="4" name="Image 0" descr="preencoded.png"/>
           <p:cNvPicPr>
             <a:picLocks noChangeAspect="1"/>
           </p:cNvPicPr>
@@ -2865,7 +2949,7 @@
       </p:sp>
       <p:pic>
         <p:nvPicPr>
-          <p:cNvPr id="6" name="Image 1" descr="preencoded.png">    </p:cNvPr>
+          <p:cNvPr id="6" name="Image 1" descr="preencoded.png"/>
           <p:cNvPicPr>
             <a:picLocks noChangeAspect="1"/>
           </p:cNvPicPr>
@@ -2950,7 +3034,7 @@
       </p:sp>
       <p:pic>
         <p:nvPicPr>
-          <p:cNvPr id="9" name="Image 2" descr="preencoded.png">    </p:cNvPr>
+          <p:cNvPr id="9" name="Image 2" descr="preencoded.png"/>
           <p:cNvPicPr>
             <a:picLocks noChangeAspect="1"/>
           </p:cNvPicPr>
@@ -3013,7 +3097,7 @@
       </p:sp>
       <p:pic>
         <p:nvPicPr>
-          <p:cNvPr id="11" name="Image 3" descr="preencoded.png">    </p:cNvPr>
+          <p:cNvPr id="11" name="Image 3" descr="preencoded.png"/>
           <p:cNvPicPr>
             <a:picLocks noChangeAspect="1"/>
           </p:cNvPicPr>
@@ -3098,7 +3182,7 @@
       </p:sp>
       <p:pic>
         <p:nvPicPr>
-          <p:cNvPr id="14" name="Image 4" descr="preencoded.png">    </p:cNvPr>
+          <p:cNvPr id="14" name="Image 4" descr="preencoded.png"/>
           <p:cNvPicPr>
             <a:picLocks noChangeAspect="1"/>
           </p:cNvPicPr>
@@ -3161,7 +3245,7 @@
       </p:sp>
       <p:pic>
         <p:nvPicPr>
-          <p:cNvPr id="16" name="Image 5" descr="preencoded.png">    </p:cNvPr>
+          <p:cNvPr id="16" name="Image 5" descr="preencoded.png"/>
           <p:cNvPicPr>
             <a:picLocks noChangeAspect="1"/>
           </p:cNvPicPr>
@@ -3246,7 +3330,7 @@
       </p:sp>
       <p:pic>
         <p:nvPicPr>
-          <p:cNvPr id="19" name="Image 6" descr="preencoded.png">    </p:cNvPr>
+          <p:cNvPr id="19" name="Image 6" descr="preencoded.png"/>
           <p:cNvPicPr>
             <a:picLocks noChangeAspect="1"/>
           </p:cNvPicPr>
@@ -4342,7 +4426,7 @@
       </p:sp>
       <p:pic>
         <p:nvPicPr>
-          <p:cNvPr id="5" name="Image 0" descr="preencoded.png">    </p:cNvPr>
+          <p:cNvPr id="5" name="Image 0" descr="preencoded.png"/>
           <p:cNvPicPr>
             <a:picLocks noChangeAspect="1"/>
           </p:cNvPicPr>
@@ -4456,7 +4540,7 @@
       </p:sp>
       <p:pic>
         <p:nvPicPr>
-          <p:cNvPr id="9" name="Image 1" descr="preencoded.png">    </p:cNvPr>
+          <p:cNvPr id="9" name="Image 1" descr="preencoded.png"/>
           <p:cNvPicPr>
             <a:picLocks noChangeAspect="1"/>
           </p:cNvPicPr>
@@ -4570,7 +4654,7 @@
       </p:sp>
       <p:pic>
         <p:nvPicPr>
-          <p:cNvPr id="13" name="Image 2" descr="preencoded.png">    </p:cNvPr>
+          <p:cNvPr id="13" name="Image 2" descr="preencoded.png"/>
           <p:cNvPicPr>
             <a:picLocks noChangeAspect="1"/>
           </p:cNvPicPr>
@@ -4684,7 +4768,7 @@
       </p:sp>
       <p:pic>
         <p:nvPicPr>
-          <p:cNvPr id="17" name="Image 3" descr="preencoded.png">    </p:cNvPr>
+          <p:cNvPr id="17" name="Image 3" descr="preencoded.png"/>
           <p:cNvPicPr>
             <a:picLocks noChangeAspect="1"/>
           </p:cNvPicPr>
@@ -4798,7 +4882,7 @@
       </p:sp>
       <p:pic>
         <p:nvPicPr>
-          <p:cNvPr id="21" name="Image 4" descr="preencoded.png">    </p:cNvPr>
+          <p:cNvPr id="21" name="Image 4" descr="preencoded.png"/>
           <p:cNvPicPr>
             <a:picLocks noChangeAspect="1"/>
           </p:cNvPicPr>
@@ -6191,7 +6275,7 @@
       </p:sp>
       <p:pic>
         <p:nvPicPr>
-          <p:cNvPr id="7" name="Image 0" descr="preencoded.png">    </p:cNvPr>
+          <p:cNvPr id="7" name="Image 0" descr="preencoded.png"/>
           <p:cNvPicPr>
             <a:picLocks noChangeAspect="1"/>
           </p:cNvPicPr>
@@ -6401,7 +6485,7 @@
       </p:sp>
       <p:pic>
         <p:nvPicPr>
-          <p:cNvPr id="14" name="Image 1" descr="preencoded.png">    </p:cNvPr>
+          <p:cNvPr id="14" name="Image 1" descr="preencoded.png"/>
           <p:cNvPicPr>
             <a:picLocks noChangeAspect="1"/>
           </p:cNvPicPr>
@@ -6611,7 +6695,7 @@
       </p:sp>
       <p:pic>
         <p:nvPicPr>
-          <p:cNvPr id="21" name="Image 2" descr="preencoded.png">    </p:cNvPr>
+          <p:cNvPr id="21" name="Image 2" descr="preencoded.png"/>
           <p:cNvPicPr>
             <a:picLocks noChangeAspect="1"/>
           </p:cNvPicPr>
@@ -6821,7 +6905,7 @@
       </p:sp>
       <p:pic>
         <p:nvPicPr>
-          <p:cNvPr id="28" name="Image 3" descr="preencoded.png">    </p:cNvPr>
+          <p:cNvPr id="28" name="Image 3" descr="preencoded.png"/>
           <p:cNvPicPr>
             <a:picLocks noChangeAspect="1"/>
           </p:cNvPicPr>
@@ -7011,7 +7095,7 @@
       </p:sp>
       <p:pic>
         <p:nvPicPr>
-          <p:cNvPr id="3" name="Image 0" descr="preencoded.png">    </p:cNvPr>
+          <p:cNvPr id="3" name="Image 0" descr="preencoded.png"/>
           <p:cNvPicPr>
             <a:picLocks noChangeAspect="1"/>
           </p:cNvPicPr>
@@ -7074,7 +7158,7 @@
       </p:sp>
       <p:pic>
         <p:nvPicPr>
-          <p:cNvPr id="5" name="Image 1" descr="preencoded.png">    </p:cNvPr>
+          <p:cNvPr id="5" name="Image 1" descr="preencoded.png"/>
           <p:cNvPicPr>
             <a:picLocks noChangeAspect="1"/>
           </p:cNvPicPr>
@@ -7137,7 +7221,7 @@
       </p:sp>
       <p:pic>
         <p:nvPicPr>
-          <p:cNvPr id="7" name="Image 2" descr="preencoded.png">    </p:cNvPr>
+          <p:cNvPr id="7" name="Image 2" descr="preencoded.png"/>
           <p:cNvPicPr>
             <a:picLocks noChangeAspect="1"/>
           </p:cNvPicPr>
@@ -7200,7 +7284,7 @@
       </p:sp>
       <p:pic>
         <p:nvPicPr>
-          <p:cNvPr id="9" name="Image 3" descr="preencoded.png">    </p:cNvPr>
+          <p:cNvPr id="9" name="Image 3" descr="preencoded.png"/>
           <p:cNvPicPr>
             <a:picLocks noChangeAspect="1"/>
           </p:cNvPicPr>
@@ -7263,7 +7347,7 @@
       </p:sp>
       <p:pic>
         <p:nvPicPr>
-          <p:cNvPr id="11" name="Image 4" descr="preencoded.png">    </p:cNvPr>
+          <p:cNvPr id="11" name="Image 4" descr="preencoded.png"/>
           <p:cNvPicPr>
             <a:picLocks noChangeAspect="1"/>
           </p:cNvPicPr>
@@ -7326,7 +7410,7 @@
       </p:sp>
       <p:pic>
         <p:nvPicPr>
-          <p:cNvPr id="13" name="Image 5" descr="preencoded.png">    </p:cNvPr>
+          <p:cNvPr id="13" name="Image 5" descr="preencoded.png"/>
           <p:cNvPicPr>
             <a:picLocks noChangeAspect="1"/>
           </p:cNvPicPr>
@@ -7389,7 +7473,7 @@
       </p:sp>
       <p:pic>
         <p:nvPicPr>
-          <p:cNvPr id="15" name="Image 6" descr="preencoded.png">    </p:cNvPr>
+          <p:cNvPr id="15" name="Image 6" descr="preencoded.png"/>
           <p:cNvPicPr>
             <a:picLocks noChangeAspect="1"/>
           </p:cNvPicPr>
@@ -7452,7 +7536,7 @@
       </p:sp>
       <p:pic>
         <p:nvPicPr>
-          <p:cNvPr id="17" name="Image 7" descr="preencoded.png">    </p:cNvPr>
+          <p:cNvPr id="17" name="Image 7" descr="preencoded.png"/>
           <p:cNvPicPr>
             <a:picLocks noChangeAspect="1"/>
           </p:cNvPicPr>
@@ -7676,7 +7760,7 @@
       </p:sp>
       <p:pic>
         <p:nvPicPr>
-          <p:cNvPr id="6" name="Image 0" descr="preencoded.png">    </p:cNvPr>
+          <p:cNvPr id="6" name="Image 0" descr="preencoded.png"/>
           <p:cNvPicPr>
             <a:picLocks noChangeAspect="1"/>
           </p:cNvPicPr>
@@ -7739,7 +7823,7 @@
       </p:sp>
       <p:pic>
         <p:nvPicPr>
-          <p:cNvPr id="8" name="Image 1" descr="preencoded.png">    </p:cNvPr>
+          <p:cNvPr id="8" name="Image 1" descr="preencoded.png"/>
           <p:cNvPicPr>
             <a:picLocks noChangeAspect="1"/>
           </p:cNvPicPr>
@@ -7802,7 +7886,7 @@
       </p:sp>
       <p:pic>
         <p:nvPicPr>
-          <p:cNvPr id="10" name="Image 2" descr="preencoded.png">    </p:cNvPr>
+          <p:cNvPr id="10" name="Image 2" descr="preencoded.png"/>
           <p:cNvPicPr>
             <a:picLocks noChangeAspect="1"/>
           </p:cNvPicPr>
@@ -9039,7 +9123,7 @@
       </p:sp>
       <p:pic>
         <p:nvPicPr>
-          <p:cNvPr id="6" name="Image 0" descr="preencoded.png">    </p:cNvPr>
+          <p:cNvPr id="6" name="Image 0" descr="preencoded.png"/>
           <p:cNvPicPr>
             <a:picLocks noChangeAspect="1"/>
           </p:cNvPicPr>
@@ -9094,7 +9178,7 @@
                 <a:ea typeface="Calibri" pitchFamily="34" charset="-122"/>
                 <a:cs typeface="Calibri" pitchFamily="34" charset="-120"/>
               </a:rPr>
-              <a:t>Confluence ENSCORP</a:t>
+              <a:t>BOE — RD 311/2022</a:t>
             </a:r>
             <a:endParaRPr lang="en-US" sz="1500" dirty="0"/>
           </a:p>
@@ -9133,7 +9217,7 @@
                 <a:ea typeface="Calibri" pitchFamily="34" charset="-122"/>
                 <a:cs typeface="Calibri" pitchFamily="34" charset="-120"/>
               </a:rPr>
-              <a:t>Base de conocimiento viva con toda la documentacion ENS</a:t>
+              <a:t>Texto completo del Esquema Nacional de Seguridad (boe.es)</a:t>
             </a:r>
             <a:endParaRPr lang="en-US" sz="1100" dirty="0"/>
           </a:p>
@@ -9212,7 +9296,7 @@
       </p:sp>
       <p:pic>
         <p:nvPicPr>
-          <p:cNvPr id="12" name="Image 1" descr="preencoded.png">    </p:cNvPr>
+          <p:cNvPr id="12" name="Image 1" descr="preencoded.png"/>
           <p:cNvPicPr>
             <a:picLocks noChangeAspect="1"/>
           </p:cNvPicPr>
@@ -9385,7 +9469,7 @@
       </p:sp>
       <p:pic>
         <p:nvPicPr>
-          <p:cNvPr id="18" name="Image 2" descr="preencoded.png">    </p:cNvPr>
+          <p:cNvPr id="18" name="Image 2" descr="preencoded.png"/>
           <p:cNvPicPr>
             <a:picLocks noChangeAspect="1"/>
           </p:cNvPicPr>
@@ -9558,7 +9642,7 @@
       </p:sp>
       <p:pic>
         <p:nvPicPr>
-          <p:cNvPr id="24" name="Image 3" descr="preencoded.png">    </p:cNvPr>
+          <p:cNvPr id="24" name="Image 3" descr="preencoded.png"/>
           <p:cNvPicPr>
             <a:picLocks noChangeAspect="1"/>
           </p:cNvPicPr>
@@ -9762,7 +9846,7 @@
       </p:sp>
       <p:pic>
         <p:nvPicPr>
-          <p:cNvPr id="4" name="Image 0" descr="preencoded.png">    </p:cNvPr>
+          <p:cNvPr id="4" name="Image 0" descr="preencoded.png"/>
           <p:cNvPicPr>
             <a:picLocks noChangeAspect="1"/>
           </p:cNvPicPr>
@@ -9808,7 +9892,7 @@
       </p:sp>
       <p:pic>
         <p:nvPicPr>
-          <p:cNvPr id="6" name="Image 1" descr="preencoded.png">    </p:cNvPr>
+          <p:cNvPr id="6" name="Image 1" descr="preencoded.png"/>
           <p:cNvPicPr>
             <a:picLocks noChangeAspect="1"/>
           </p:cNvPicPr>
@@ -9902,7 +9986,7 @@
       </p:sp>
       <p:pic>
         <p:nvPicPr>
-          <p:cNvPr id="9" name="Image 2" descr="preencoded.png">    </p:cNvPr>
+          <p:cNvPr id="9" name="Image 2" descr="preencoded.png"/>
           <p:cNvPicPr>
             <a:picLocks noChangeAspect="1"/>
           </p:cNvPicPr>
@@ -9948,7 +10032,7 @@
       </p:sp>
       <p:pic>
         <p:nvPicPr>
-          <p:cNvPr id="11" name="Image 3" descr="preencoded.png">    </p:cNvPr>
+          <p:cNvPr id="11" name="Image 3" descr="preencoded.png"/>
           <p:cNvPicPr>
             <a:picLocks noChangeAspect="1"/>
           </p:cNvPicPr>
@@ -10042,7 +10126,7 @@
       </p:sp>
       <p:pic>
         <p:nvPicPr>
-          <p:cNvPr id="14" name="Image 4" descr="preencoded.png">    </p:cNvPr>
+          <p:cNvPr id="14" name="Image 4" descr="preencoded.png"/>
           <p:cNvPicPr>
             <a:picLocks noChangeAspect="1"/>
           </p:cNvPicPr>
@@ -10088,7 +10172,7 @@
       </p:sp>
       <p:pic>
         <p:nvPicPr>
-          <p:cNvPr id="16" name="Image 5" descr="preencoded.png">    </p:cNvPr>
+          <p:cNvPr id="16" name="Image 5" descr="preencoded.png"/>
           <p:cNvPicPr>
             <a:picLocks noChangeAspect="1"/>
           </p:cNvPicPr>
@@ -10307,7 +10391,7 @@
       </p:sp>
       <p:pic>
         <p:nvPicPr>
-          <p:cNvPr id="4" name="Image 0" descr="preencoded.png">    </p:cNvPr>
+          <p:cNvPr id="4" name="Image 0" descr="preencoded.png"/>
           <p:cNvPicPr>
             <a:picLocks noChangeAspect="1"/>
           </p:cNvPicPr>
@@ -10329,6 +10413,469 @@
           </a:prstGeom>
         </p:spPr>
       </p:pic>
+    </p:spTree>
+  </p:cSld>
+  <p:clrMapOvr>
+    <a:masterClrMapping/>
+  </p:clrMapOvr>
+</p:sld>
+</file>
+
+<file path=ppt/slides/slide21.xml><?xml version="1.0" encoding="utf-8"?>
+<p:sld xmlns:a="http://schemas.openxmlformats.org/drawingml/2006/main" xmlns:r="http://schemas.openxmlformats.org/officeDocument/2006/relationships" xmlns:p="http://schemas.openxmlformats.org/presentationml/2006/main">
+  <p:cSld name="Slide 15">
+    <p:bg>
+      <p:bgPr>
+        <a:solidFill>
+          <a:srgbClr val="F7FAF9"/>
+        </a:solidFill>
+      </p:bgPr>
+    </p:bg>
+    <p:spTree>
+      <p:nvGrpSpPr>
+        <p:cNvPr id="1" name=""/>
+        <p:cNvGrpSpPr/>
+        <p:nvPr/>
+      </p:nvGrpSpPr>
+      <p:grpSpPr>
+        <a:xfrm>
+          <a:off x="0" y="0"/>
+          <a:ext cx="0" cy="0"/>
+          <a:chOff x="0" y="0"/>
+          <a:chExt cx="0" cy="0"/>
+        </a:xfrm>
+      </p:grpSpPr>
+      <p:sp>
+        <p:nvSpPr>
+          <p:cNvPr id="2" name="Text 0"/>
+          <p:cNvSpPr/>
+          <p:nvPr/>
+        </p:nvSpPr>
+        <p:spPr>
+          <a:xfrm>
+            <a:off x="548640" y="274320"/>
+            <a:ext cx="7315200" cy="457200"/>
+          </a:xfrm>
+          <a:prstGeom prst="rect">
+            <a:avLst/>
+          </a:prstGeom>
+          <a:noFill/>
+          <a:ln/>
+        </p:spPr>
+        <p:txBody>
+          <a:bodyPr wrap="square" rtlCol="0" anchor="ctr"/>
+          <a:lstStyle/>
+          <a:p>
+            <a:pPr indent="0" marL="0">
+              <a:buNone/>
+            </a:pPr>
+            <a:r>
+              <a:rPr lang="en-US" sz="2200" b="1" dirty="0">
+                <a:solidFill>
+                  <a:srgbClr val="0D9A76"/>
+                </a:solidFill>
+                <a:latin typeface="Calibri" pitchFamily="34" charset="0"/>
+                <a:ea typeface="Calibri" pitchFamily="34" charset="-122"/>
+                <a:cs typeface="Calibri" pitchFamily="34" charset="-120"/>
+              </a:rPr>
+              <a:t>Nuevas Herramientas = Nuevo Tratamiento de Datos</a:t>
+            </a:r>
+            <a:endParaRPr lang="en-US" sz="2200" dirty="0"/>
+          </a:p>
+        </p:txBody>
+      </p:sp>
+      <p:sp>
+        <p:nvSpPr>
+          <p:cNvPr id="3" name="Shape 1"/>
+          <p:cNvSpPr/>
+          <p:nvPr/>
+        </p:nvSpPr>
+        <p:spPr>
+          <a:xfrm>
+            <a:off x="640080" y="914400"/>
+            <a:ext cx="3657600" cy="3474720"/>
+          </a:xfrm>
+          <a:prstGeom prst="roundRect">
+            <a:avLst>
+              <a:gd name="adj" fmla="val 2105"/>
+            </a:avLst>
+          </a:prstGeom>
+          <a:solidFill>
+            <a:srgbClr val="FFFFFF"/>
+          </a:solidFill>
+          <a:ln/>
+          <a:effectLst>
+            <a:outerShdw sx="100000" sy="100000" kx="0" ky="0" algn="bl" rotWithShape="0" blurRad="50800" dist="25400" dir="8100000">
+              <a:srgbClr val="000000">
+                <a:alpha val="10000"/>
+              </a:srgbClr>
+            </a:outerShdw>
+          </a:effectLst>
+        </p:spPr>
+      </p:sp>
+      <p:sp>
+        <p:nvSpPr>
+          <p:cNvPr id="4" name="Shape 2"/>
+          <p:cNvSpPr/>
+          <p:nvPr/>
+        </p:nvSpPr>
+        <p:spPr>
+          <a:xfrm>
+            <a:off x="640080" y="914400"/>
+            <a:ext cx="54864" cy="3474720"/>
+          </a:xfrm>
+          <a:prstGeom prst="rect">
+            <a:avLst>
+              <a:gd name="adj" fmla="val 50000"/>
+            </a:avLst>
+          </a:prstGeom>
+          <a:solidFill>
+            <a:srgbClr val="0D9A76"/>
+          </a:solidFill>
+          <a:ln/>
+        </p:spPr>
+      </p:sp>
+      <p:sp>
+        <p:nvSpPr>
+          <p:cNvPr id="5" name="Text 3"/>
+          <p:cNvSpPr/>
+          <p:nvPr/>
+        </p:nvSpPr>
+        <p:spPr>
+          <a:xfrm>
+            <a:off x="822960" y="1051560"/>
+            <a:ext cx="3291840" cy="320040"/>
+          </a:xfrm>
+          <a:prstGeom prst="rect">
+            <a:avLst/>
+          </a:prstGeom>
+          <a:noFill/>
+          <a:ln/>
+        </p:spPr>
+        <p:txBody>
+          <a:bodyPr wrap="square" lIns="0" tIns="0" rIns="0" bIns="0" rtlCol="0" anchor="ctr"/>
+          <a:lstStyle/>
+          <a:p>
+            <a:pPr indent="0" marL="0">
+              <a:buNone/>
+            </a:pPr>
+            <a:r>
+              <a:rPr lang="en-US" sz="1400" b="1" dirty="0">
+                <a:solidFill>
+                  <a:srgbClr val="0D9A76"/>
+                </a:solidFill>
+                <a:latin typeface="Calibri" pitchFamily="34" charset="0"/>
+                <a:ea typeface="Calibri" pitchFamily="34" charset="-122"/>
+                <a:cs typeface="Calibri" pitchFamily="34" charset="-120"/>
+              </a:rPr>
+              <a:t>Cuando actualizar el RAT (D11)</a:t>
+            </a:r>
+            <a:endParaRPr lang="en-US" sz="1400" dirty="0"/>
+          </a:p>
+        </p:txBody>
+      </p:sp>
+      <p:sp>
+        <p:nvSpPr>
+          <p:cNvPr id="6" name="Text 4"/>
+          <p:cNvSpPr/>
+          <p:nvPr/>
+        </p:nvSpPr>
+        <p:spPr>
+          <a:xfrm>
+            <a:off x="822960" y="1463040"/>
+            <a:ext cx="3291840" cy="2743200"/>
+          </a:xfrm>
+          <a:prstGeom prst="rect">
+            <a:avLst/>
+          </a:prstGeom>
+          <a:noFill/>
+          <a:ln/>
+        </p:spPr>
+        <p:txBody>
+          <a:bodyPr wrap="square" lIns="0" tIns="0" rIns="0" bIns="0" rtlCol="0" anchor="ctr"/>
+          <a:lstStyle/>
+          <a:p>
+            <a:pPr marL="342900" indent="-342900">
+              <a:spcAft>
+                <a:spcPts val="600"/>
+              </a:spcAft>
+              <a:buSzPct val="100000"/>
+              <a:buChar char="•"/>
+            </a:pPr>
+            <a:r>
+              <a:rPr lang="en-US" sz="1200" dirty="0">
+                <a:solidFill>
+                  <a:srgbClr val="2D3748"/>
+                </a:solidFill>
+                <a:latin typeface="Calibri" pitchFamily="34" charset="0"/>
+                <a:ea typeface="Calibri" pitchFamily="34" charset="-122"/>
+                <a:cs typeface="Calibri" pitchFamily="34" charset="-120"/>
+              </a:rPr>
+              <a:t>Nueva herramienta que trata datos personales (HubSpot, LinkedIn Ads, Mailchimp...)</a:t>
+            </a:r>
+            <a:endParaRPr lang="en-US" sz="1200" dirty="0"/>
+          </a:p>
+          <a:p>
+            <a:pPr marL="342900" indent="-342900">
+              <a:spcAft>
+                <a:spcPts val="600"/>
+              </a:spcAft>
+              <a:buSzPct val="100000"/>
+              <a:buChar char="•"/>
+            </a:pPr>
+            <a:r>
+              <a:rPr lang="en-US" sz="1200" dirty="0">
+                <a:solidFill>
+                  <a:srgbClr val="2D3748"/>
+                </a:solidFill>
+                <a:latin typeface="Calibri" pitchFamily="34" charset="0"/>
+                <a:ea typeface="Calibri" pitchFamily="34" charset="-122"/>
+                <a:cs typeface="Calibri" pitchFamily="34" charset="-120"/>
+              </a:rPr>
+              <a:t>Nueva actividad de tratamiento no cubierta en el registro actual</a:t>
+            </a:r>
+            <a:endParaRPr lang="en-US" sz="1200" dirty="0"/>
+          </a:p>
+          <a:p>
+            <a:pPr marL="342900" indent="-342900">
+              <a:spcAft>
+                <a:spcPts val="600"/>
+              </a:spcAft>
+              <a:buSzPct val="100000"/>
+              <a:buChar char="•"/>
+            </a:pPr>
+            <a:r>
+              <a:rPr lang="en-US" sz="1200" dirty="0">
+                <a:solidFill>
+                  <a:srgbClr val="2D3748"/>
+                </a:solidFill>
+                <a:latin typeface="Calibri" pitchFamily="34" charset="0"/>
+                <a:ea typeface="Calibri" pitchFamily="34" charset="-122"/>
+                <a:cs typeface="Calibri" pitchFamily="34" charset="-120"/>
+              </a:rPr>
+              <a:t>Nuevo proveedor con acceso a datos personales</a:t>
+            </a:r>
+            <a:endParaRPr lang="en-US" sz="1200" dirty="0"/>
+          </a:p>
+          <a:p>
+            <a:pPr marL="342900" indent="-342900">
+              <a:spcAft>
+                <a:spcPts val="600"/>
+              </a:spcAft>
+              <a:buSzPct val="100000"/>
+              <a:buChar char="•"/>
+            </a:pPr>
+            <a:r>
+              <a:rPr lang="en-US" sz="1200" dirty="0">
+                <a:solidFill>
+                  <a:srgbClr val="2D3748"/>
+                </a:solidFill>
+                <a:latin typeface="Calibri" pitchFamily="34" charset="0"/>
+                <a:ea typeface="Calibri" pitchFamily="34" charset="-122"/>
+                <a:cs typeface="Calibri" pitchFamily="34" charset="-120"/>
+              </a:rPr>
+              <a:t>Cambio en la finalidad del tratamiento existente</a:t>
+            </a:r>
+            <a:endParaRPr lang="en-US" sz="1200" dirty="0"/>
+          </a:p>
+        </p:txBody>
+      </p:sp>
+      <p:sp>
+        <p:nvSpPr>
+          <p:cNvPr id="7" name="Shape 5"/>
+          <p:cNvSpPr/>
+          <p:nvPr/>
+        </p:nvSpPr>
+        <p:spPr>
+          <a:xfrm>
+            <a:off x="4846320" y="914400"/>
+            <a:ext cx="3657600" cy="3474720"/>
+          </a:xfrm>
+          <a:prstGeom prst="roundRect">
+            <a:avLst>
+              <a:gd name="adj" fmla="val 2105"/>
+            </a:avLst>
+          </a:prstGeom>
+          <a:solidFill>
+            <a:srgbClr val="FFFFFF"/>
+          </a:solidFill>
+          <a:ln/>
+          <a:effectLst>
+            <a:outerShdw sx="100000" sy="100000" kx="0" ky="0" algn="bl" rotWithShape="0" blurRad="50800" dist="25400" dir="8100000">
+              <a:srgbClr val="000000">
+                <a:alpha val="10000"/>
+              </a:srgbClr>
+            </a:outerShdw>
+          </a:effectLst>
+        </p:spPr>
+      </p:sp>
+      <p:sp>
+        <p:nvSpPr>
+          <p:cNvPr id="8" name="Shape 6"/>
+          <p:cNvSpPr/>
+          <p:nvPr/>
+        </p:nvSpPr>
+        <p:spPr>
+          <a:xfrm>
+            <a:off x="4846320" y="914400"/>
+            <a:ext cx="54864" cy="3474720"/>
+          </a:xfrm>
+          <a:prstGeom prst="rect">
+            <a:avLst>
+              <a:gd name="adj" fmla="val 50000"/>
+            </a:avLst>
+          </a:prstGeom>
+          <a:solidFill>
+            <a:srgbClr val="0D9A76"/>
+          </a:solidFill>
+          <a:ln/>
+        </p:spPr>
+      </p:sp>
+      <p:sp>
+        <p:nvSpPr>
+          <p:cNvPr id="9" name="Text 7"/>
+          <p:cNvSpPr/>
+          <p:nvPr/>
+        </p:nvSpPr>
+        <p:spPr>
+          <a:xfrm>
+            <a:off x="5029200" y="1051560"/>
+            <a:ext cx="3291840" cy="320040"/>
+          </a:xfrm>
+          <a:prstGeom prst="rect">
+            <a:avLst/>
+          </a:prstGeom>
+          <a:noFill/>
+          <a:ln/>
+        </p:spPr>
+        <p:txBody>
+          <a:bodyPr wrap="square" lIns="0" tIns="0" rIns="0" bIns="0" rtlCol="0" anchor="ctr"/>
+          <a:lstStyle/>
+          <a:p>
+            <a:pPr indent="0" marL="0">
+              <a:buNone/>
+            </a:pPr>
+            <a:r>
+              <a:rPr lang="en-US" sz="1400" b="1" dirty="0">
+                <a:solidFill>
+                  <a:srgbClr val="0D9A76"/>
+                </a:solidFill>
+                <a:latin typeface="Calibri" pitchFamily="34" charset="0"/>
+                <a:ea typeface="Calibri" pitchFamily="34" charset="-122"/>
+                <a:cs typeface="Calibri" pitchFamily="34" charset="-120"/>
+              </a:rPr>
+              <a:t>Como notificarlo</a:t>
+            </a:r>
+            <a:endParaRPr lang="en-US" sz="1400" dirty="0"/>
+          </a:p>
+        </p:txBody>
+      </p:sp>
+      <p:sp>
+        <p:nvSpPr>
+          <p:cNvPr id="10" name="Text 8"/>
+          <p:cNvSpPr/>
+          <p:nvPr/>
+        </p:nvSpPr>
+        <p:spPr>
+          <a:xfrm>
+            <a:off x="5029200" y="1463040"/>
+            <a:ext cx="3291840" cy="2743200"/>
+          </a:xfrm>
+          <a:prstGeom prst="rect">
+            <a:avLst/>
+          </a:prstGeom>
+          <a:noFill/>
+          <a:ln/>
+        </p:spPr>
+        <p:txBody>
+          <a:bodyPr wrap="square" lIns="0" tIns="0" rIns="0" bIns="0" rtlCol="0" anchor="ctr"/>
+          <a:lstStyle/>
+          <a:p>
+            <a:pPr marL="342900" indent="-342900">
+              <a:spcAft>
+                <a:spcPts val="600"/>
+              </a:spcAft>
+              <a:buSzPct val="100000"/>
+              <a:buChar char="•"/>
+            </a:pPr>
+            <a:r>
+              <a:rPr lang="en-US" sz="1200" dirty="0">
+                <a:solidFill>
+                  <a:srgbClr val="2D3748"/>
+                </a:solidFill>
+                <a:latin typeface="Calibri" pitchFamily="34" charset="0"/>
+                <a:ea typeface="Calibri" pitchFamily="34" charset="-122"/>
+                <a:cs typeface="Calibri" pitchFamily="34" charset="-120"/>
+              </a:rPr>
+              <a:t>Opcion 1: Crear ticket en Jira Service Management (tipo: “Solicitud de cambio ENS”)</a:t>
+            </a:r>
+            <a:endParaRPr lang="en-US" sz="1200" dirty="0"/>
+          </a:p>
+          <a:p>
+            <a:pPr marL="342900" indent="-342900">
+              <a:spcAft>
+                <a:spcPts val="600"/>
+              </a:spcAft>
+              <a:buSzPct val="100000"/>
+              <a:buChar char="•"/>
+            </a:pPr>
+            <a:r>
+              <a:rPr lang="en-US" sz="1200" dirty="0">
+                <a:solidFill>
+                  <a:srgbClr val="2D3748"/>
+                </a:solidFill>
+                <a:latin typeface="Calibri" pitchFamily="34" charset="0"/>
+                <a:ea typeface="Calibri" pitchFamily="34" charset="-122"/>
+                <a:cs typeface="Calibri" pitchFamily="34" charset="-120"/>
+              </a:rPr>
+              <a:t>Opcion 2: Contactar directamente al DPO o Resp. Seguridad</a:t>
+            </a:r>
+            <a:endParaRPr lang="en-US" sz="1200" dirty="0"/>
+          </a:p>
+          <a:p>
+            <a:pPr marL="342900" indent="-342900">
+              <a:spcAft>
+                <a:spcPts val="600"/>
+              </a:spcAft>
+              <a:buSzPct val="100000"/>
+              <a:buChar char="•"/>
+            </a:pPr>
+            <a:r>
+              <a:rPr lang="en-US" sz="1200" b="1" dirty="0">
+                <a:solidFill>
+                  <a:srgbClr val="2D3748"/>
+                </a:solidFill>
+                <a:latin typeface="Calibri" pitchFamily="34" charset="0"/>
+                <a:ea typeface="Calibri" pitchFamily="34" charset="-122"/>
+                <a:cs typeface="Calibri" pitchFamily="34" charset="-120"/>
+              </a:rPr>
+              <a:t>Obligatorio ANTES de empezar a usar la herramienta</a:t>
+            </a:r>
+            <a:endParaRPr lang="en-US" sz="1200" dirty="0"/>
+          </a:p>
+          <a:p>
+            <a:pPr marL="342900" indent="-342900">
+              <a:spcAft>
+                <a:spcPts val="600"/>
+              </a:spcAft>
+              <a:buSzPct val="100000"/>
+              <a:buChar char="•"/>
+            </a:pPr>
+            <a:r>
+              <a:rPr lang="en-US" sz="1200" dirty="0">
+                <a:solidFill>
+                  <a:srgbClr val="2D3748"/>
+                </a:solidFill>
+                <a:latin typeface="Calibri" pitchFamily="34" charset="0"/>
+                <a:ea typeface="Calibri" pitchFamily="34" charset="-122"/>
+                <a:cs typeface="Calibri" pitchFamily="34" charset="-120"/>
+              </a:rPr>
+              <a:t>El DPO evaluara si requiere EIPD (Evaluacion de Impacto)</a:t>
+            </a:r>
+            <a:endParaRPr lang="en-US" sz="1200" dirty="0"/>
+          </a:p>
+        </p:txBody>
+      </p:sp>
     </p:spTree>
   </p:cSld>
   <p:clrMapOvr>
@@ -10929,7 +11476,7 @@
       </p:sp>
       <p:pic>
         <p:nvPicPr>
-          <p:cNvPr id="6" name="Image 0" descr="preencoded.png">    </p:cNvPr>
+          <p:cNvPr id="6" name="Image 0" descr="preencoded.png"/>
           <p:cNvPicPr>
             <a:picLocks noChangeAspect="1"/>
           </p:cNvPicPr>
@@ -11102,7 +11649,7 @@
       </p:sp>
       <p:pic>
         <p:nvPicPr>
-          <p:cNvPr id="12" name="Image 1" descr="preencoded.png">    </p:cNvPr>
+          <p:cNvPr id="12" name="Image 1" descr="preencoded.png"/>
           <p:cNvPicPr>
             <a:picLocks noChangeAspect="1"/>
           </p:cNvPicPr>
@@ -11275,7 +11822,7 @@
       </p:sp>
       <p:pic>
         <p:nvPicPr>
-          <p:cNvPr id="18" name="Image 2" descr="preencoded.png">    </p:cNvPr>
+          <p:cNvPr id="18" name="Image 2" descr="preencoded.png"/>
           <p:cNvPicPr>
             <a:picLocks noChangeAspect="1"/>
           </p:cNvPicPr>
@@ -13392,7 +13939,7 @@
       </p:sp>
       <p:pic>
         <p:nvPicPr>
-          <p:cNvPr id="5" name="Image 0" descr="preencoded.png">    </p:cNvPr>
+          <p:cNvPr id="5" name="Image 0" descr="preencoded.png"/>
           <p:cNvPicPr>
             <a:picLocks noChangeAspect="1"/>
           </p:cNvPicPr>
@@ -13543,7 +14090,7 @@
       </p:sp>
       <p:pic>
         <p:nvPicPr>
-          <p:cNvPr id="10" name="Image 1" descr="preencoded.png">    </p:cNvPr>
+          <p:cNvPr id="10" name="Image 1" descr="preencoded.png"/>
           <p:cNvPicPr>
             <a:picLocks noChangeAspect="1"/>
           </p:cNvPicPr>
@@ -13694,7 +14241,7 @@
       </p:sp>
       <p:pic>
         <p:nvPicPr>
-          <p:cNvPr id="15" name="Image 2" descr="preencoded.png">    </p:cNvPr>
+          <p:cNvPr id="15" name="Image 2" descr="preencoded.png"/>
           <p:cNvPicPr>
             <a:picLocks noChangeAspect="1"/>
           </p:cNvPicPr>
@@ -13845,7 +14392,7 @@
       </p:sp>
       <p:pic>
         <p:nvPicPr>
-          <p:cNvPr id="20" name="Image 3" descr="preencoded.png">    </p:cNvPr>
+          <p:cNvPr id="20" name="Image 3" descr="preencoded.png"/>
           <p:cNvPicPr>
             <a:picLocks noChangeAspect="1"/>
           </p:cNvPicPr>
@@ -13996,7 +14543,7 @@
       </p:sp>
       <p:pic>
         <p:nvPicPr>
-          <p:cNvPr id="25" name="Image 4" descr="preencoded.png">    </p:cNvPr>
+          <p:cNvPr id="25" name="Image 4" descr="preencoded.png"/>
           <p:cNvPicPr>
             <a:picLocks noChangeAspect="1"/>
           </p:cNvPicPr>
@@ -14220,7 +14767,7 @@
       </p:sp>
       <p:pic>
         <p:nvPicPr>
-          <p:cNvPr id="5" name="Image 0" descr="preencoded.png">    </p:cNvPr>
+          <p:cNvPr id="5" name="Image 0" descr="preencoded.png"/>
           <p:cNvPicPr>
             <a:picLocks noChangeAspect="1"/>
           </p:cNvPicPr>
@@ -14373,7 +14920,7 @@
       </p:sp>
       <p:pic>
         <p:nvPicPr>
-          <p:cNvPr id="10" name="Image 1" descr="preencoded.png">    </p:cNvPr>
+          <p:cNvPr id="10" name="Image 1" descr="preencoded.png"/>
           <p:cNvPicPr>
             <a:picLocks noChangeAspect="1"/>
           </p:cNvPicPr>
@@ -14526,7 +15073,7 @@
       </p:sp>
       <p:pic>
         <p:nvPicPr>
-          <p:cNvPr id="15" name="Image 2" descr="preencoded.png">    </p:cNvPr>
+          <p:cNvPr id="15" name="Image 2" descr="preencoded.png"/>
           <p:cNvPicPr>
             <a:picLocks noChangeAspect="1"/>
           </p:cNvPicPr>
@@ -14679,7 +15226,7 @@
       </p:sp>
       <p:pic>
         <p:nvPicPr>
-          <p:cNvPr id="20" name="Image 3" descr="preencoded.png">    </p:cNvPr>
+          <p:cNvPr id="20" name="Image 3" descr="preencoded.png"/>
           <p:cNvPicPr>
             <a:picLocks noChangeAspect="1"/>
           </p:cNvPicPr>

</xml_diff>

<commit_message>
feat: update presentation files for ENS team in DOCX and PPTX formats
</commit_message>
<xml_diff>
--- a/08_GOBERNANZA/Presentacion ENS equipo optimTech.pptx
+++ b/08_GOBERNANZA/Presentacion ENS equipo optimTech.pptx
@@ -20,6 +20,7 @@
     <p:sldId id="268" r:id="rId14"/>
     <p:sldId id="269" r:id="rId15"/>
     <p:sldId id="276" r:id="rId27"/>
+    <p:sldId id="277" r:id="rId28"/>
     <p:sldId id="270" r:id="rId16"/>
     <p:sldId id="271" r:id="rId17"/>
     <p:sldId id="272" r:id="rId18"/>
@@ -1696,6 +1697,94 @@
         </p:txBody>
       </p:sp>
     </p:spTree>
+  </p:cSld>
+  <p:clrMapOvr>
+    <a:masterClrMapping/>
+  </p:clrMapOvr>
+</p:notes>
+</file>
+
+<file path=ppt/notesSlides/notesSlide22.xml><?xml version="1.0" encoding="utf-8"?>
+<p:notes xmlns:a="http://schemas.openxmlformats.org/drawingml/2006/main" xmlns:r="http://schemas.openxmlformats.org/officeDocument/2006/relationships" xmlns:p="http://schemas.openxmlformats.org/presentationml/2006/main">
+  <p:cSld>
+    <p:spTree>
+      <p:nvGrpSpPr>
+        <p:cNvPr id="1" name=""/>
+        <p:cNvGrpSpPr/>
+        <p:nvPr/>
+      </p:nvGrpSpPr>
+      <p:grpSpPr>
+        <a:xfrm>
+          <a:off x="0" y="0"/>
+          <a:ext cx="0" cy="0"/>
+          <a:chOff x="0" y="0"/>
+          <a:chExt cx="0" cy="0"/>
+        </a:xfrm>
+      </p:grpSpPr>
+      <p:sp>
+        <p:nvSpPr>
+          <p:cNvPr id="2" name="Slide Image Placeholder 1"/>
+          <p:cNvSpPr>
+            <a:spLocks noGrp="1" noRot="1" noChangeAspect="1"/>
+          </p:cNvSpPr>
+          <p:nvPr>
+            <p:ph type="sldImg"/>
+          </p:nvPr>
+        </p:nvSpPr>
+        <p:spPr/>
+      </p:sp>
+      <p:sp>
+        <p:nvSpPr>
+          <p:cNvPr id="3" name="Notes Placeholder 2"/>
+          <p:cNvSpPr>
+            <a:spLocks noGrp="1"/>
+          </p:cNvSpPr>
+          <p:nvPr>
+            <p:ph type="body" idx="1"/>
+          </p:nvPr>
+        </p:nvSpPr>
+        <p:spPr/>
+        <p:txBody>
+          <a:bodyPr/>
+          <a:lstStyle/>
+          <a:p>
+            <a:r>
+              <a:rPr lang="es-ES" dirty="0"/>
+              <a:t>Tiempo estimado: 3 minutos. Enfatizar que JSM no es burocracia sino trazabilidad. Poner ejemplos concretos del equipo de marketing/ventas. Recordar que ante duda, siempre pueden preguntar al CISO.</a:t>
+            </a:r>
+            <a:endParaRPr lang="es-ES" dirty="0"/>
+          </a:p>
+        </p:txBody>
+      </p:sp>
+      <p:sp>
+        <p:nvSpPr>
+          <p:cNvPr id="4" name="Slide Number Placeholder 3"/>
+          <p:cNvSpPr>
+            <a:spLocks noGrp="1"/>
+          </p:cNvSpPr>
+          <p:nvPr>
+            <p:ph type="sldNum" sz="quarter" idx="10"/>
+          </p:nvPr>
+        </p:nvSpPr>
+        <p:spPr/>
+        <p:txBody>
+          <a:bodyPr/>
+          <a:lstStyle/>
+          <a:p>
+            <a:fld id="{A1B2C3D4-E5F6-7890-ABCD-EF1234567890}" type="slidenum">
+              <a:rPr lang="es-ES"/>
+              <a:t>22</a:t>
+            </a:fld>
+            <a:endParaRPr lang="es-ES"/>
+          </a:p>
+        </p:txBody>
+      </p:sp>
+    </p:spTree>
+    <p:extLst>
+      <p:ext uri="{BB962C8B-B14F-4D97-AF65-F5344CB8AC3E}">
+        <p14:creationId xmlns:p14="http://schemas.microsoft.com/office/powerpoint/2010/main" val="2048173982"/>
+      </p:ext>
+    </p:extLst>
   </p:cSld>
   <p:clrMapOvr>
     <a:masterClrMapping/>
@@ -10884,6 +10973,765 @@
 </p:sld>
 </file>
 
+<file path=ppt/slides/slide22.xml><?xml version="1.0" encoding="utf-8"?>
+<p:sld xmlns:a="http://schemas.openxmlformats.org/drawingml/2006/main" xmlns:r="http://schemas.openxmlformats.org/officeDocument/2006/relationships" xmlns:p="http://schemas.openxmlformats.org/presentationml/2006/main">
+  <p:cSld name="Slide 22">
+    <p:bg>
+      <p:bgPr>
+        <a:solidFill>
+          <a:srgbClr val="F7FAF9"/>
+        </a:solidFill>
+      </p:bgPr>
+    </p:bg>
+    <p:spTree>
+      <p:nvGrpSpPr>
+        <p:cNvPr id="1" name=""/>
+        <p:cNvGrpSpPr/>
+        <p:nvPr/>
+      </p:nvGrpSpPr>
+      <p:grpSpPr>
+        <a:xfrm>
+          <a:off x="0" y="0"/>
+          <a:ext cx="0" cy="0"/>
+          <a:chOff x="0" y="0"/>
+          <a:chExt cx="0" cy="0"/>
+        </a:xfrm>
+      </p:grpSpPr>
+      <p:sp>
+        <p:nvSpPr>
+          <p:cNvPr id="2" name="Title"/>
+          <p:cNvSpPr/>
+          <p:nvPr/>
+        </p:nvSpPr>
+        <p:spPr>
+          <a:xfrm>
+            <a:off x="548640" y="228600"/>
+            <a:ext cx="8046720" cy="457200"/>
+          </a:xfrm>
+          <a:prstGeom prst="rect">
+            <a:avLst/>
+          </a:prstGeom>
+          <a:noFill/>
+          <a:ln/>
+        </p:spPr>
+        <p:txBody>
+          <a:bodyPr wrap="square" rtlCol="0" anchor="ctr"/>
+          <a:lstStyle/>
+          <a:p>
+            <a:pPr indent="0" marL="0">
+              <a:buNone/>
+            </a:pPr>
+            <a:r>
+              <a:rPr lang="es-ES" sz="2000" b="1" dirty="0">
+                <a:solidFill>
+                  <a:srgbClr val="0D9A76"/>
+                </a:solidFill>
+                <a:latin typeface="Calibri" pitchFamily="34" charset="0"/>
+                <a:ea typeface="Calibri" pitchFamily="34" charset="-122"/>
+                <a:cs typeface="Calibri" pitchFamily="34" charset="-120"/>
+              </a:rPr>
+              <a:t>¿Cuando uso Jira Service Management (JSM)?</a:t>
+            </a:r>
+            <a:endParaRPr lang="es-ES" sz="2000" dirty="0"/>
+          </a:p>
+        </p:txBody>
+      </p:sp>
+      <p:graphicFrame>
+        <p:nvGraphicFramePr>
+          <p:cNvPr id="3" name="Table 1"/>
+          <p:cNvGraphicFramePr>
+            <a:graphicFrameLocks noGrp="1"/>
+          </p:cNvGraphicFramePr>
+          <p:nvPr/>
+        </p:nvGraphicFramePr>
+        <p:xfrm>
+          <a:off x="457200" y="777240"/>
+          <a:ext cx="8229600" cy="3200400"/>
+        </p:xfrm>
+        <a:graphic>
+          <a:graphicData uri="http://schemas.openxmlformats.org/drawingml/2006/table">
+            <a:tbl>
+              <a:tblPr firstRow="1" bandRow="1">
+                <a:tblStyle val="{5C22544A-7EE6-4342-B048-85BDC9FD1C3A}"/>
+              </a:tblPr>
+              <a:tblGrid>
+                <a:gridCol w="4114800"/>
+                <a:gridCol w="4114800"/>
+              </a:tblGrid>
+              <a:tr h="365760">
+                <a:tc>
+                  <a:txBody>
+                    <a:bodyPr/>
+                    <a:lstStyle/>
+                    <a:p>
+                      <a:pPr algn="l"/>
+                      <a:r>
+                        <a:rPr lang="es-ES" sz="1200" b="1" dirty="0">
+                          <a:solidFill>
+                            <a:srgbClr val="FFFFFF"/>
+                          </a:solidFill>
+                          <a:latin typeface="Calibri" pitchFamily="34" charset="0"/>
+                        </a:rPr>
+                        <a:t>✅  Usa JSM cuando...</a:t>
+                      </a:r>
+                    </a:p>
+                  </a:txBody>
+                  <a:tcPr marL="91440" marR="91440" marT="45720" marB="45720">
+                    <a:lnL w="12700">
+                      <a:solidFill>
+                        <a:srgbClr val="0D9A76"/>
+                      </a:solidFill>
+                    </a:lnL>
+                    <a:lnR w="12700">
+                      <a:solidFill>
+                        <a:srgbClr val="0D9A76"/>
+                      </a:solidFill>
+                    </a:lnR>
+                    <a:lnT w="12700">
+                      <a:solidFill>
+                        <a:srgbClr val="0D9A76"/>
+                      </a:solidFill>
+                    </a:lnT>
+                    <a:lnB w="12700">
+                      <a:solidFill>
+                        <a:srgbClr val="0D9A76"/>
+                      </a:solidFill>
+                    </a:lnB>
+                    <a:solidFill>
+                      <a:srgbClr val="0D9A76"/>
+                    </a:solidFill>
+                  </a:tcPr>
+                </a:tc>
+                <a:tc>
+                  <a:txBody>
+                    <a:bodyPr/>
+                    <a:lstStyle/>
+                    <a:p>
+                      <a:pPr algn="l"/>
+                      <a:r>
+                        <a:rPr lang="es-ES" sz="1200" b="1" dirty="0">
+                          <a:solidFill>
+                            <a:srgbClr val="FFFFFF"/>
+                          </a:solidFill>
+                          <a:latin typeface="Calibri" pitchFamily="34" charset="0"/>
+                        </a:rPr>
+                        <a:t>❌  NO necesitas JSM para...</a:t>
+                      </a:r>
+                    </a:p>
+                  </a:txBody>
+                  <a:tcPr marL="91440" marR="91440" marT="45720" marB="45720">
+                    <a:lnL w="12700">
+                      <a:solidFill>
+                        <a:srgbClr val="C53030"/>
+                      </a:solidFill>
+                    </a:lnL>
+                    <a:lnR w="12700">
+                      <a:solidFill>
+                        <a:srgbClr val="C53030"/>
+                      </a:solidFill>
+                    </a:lnR>
+                    <a:lnT w="12700">
+                      <a:solidFill>
+                        <a:srgbClr val="C53030"/>
+                      </a:solidFill>
+                    </a:lnT>
+                    <a:lnB w="12700">
+                      <a:solidFill>
+                        <a:srgbClr val="C53030"/>
+                      </a:solidFill>
+                    </a:lnB>
+                    <a:solidFill>
+                      <a:srgbClr val="C53030"/>
+                    </a:solidFill>
+                  </a:tcPr>
+                </a:tc>
+              </a:tr>
+              <a:tr h="365760">
+                <a:tc>
+                  <a:txBody>
+                    <a:bodyPr/>
+                    <a:lstStyle/>
+                    <a:p>
+                      <a:r>
+                        <a:rPr lang="es-ES" sz="1100" dirty="0">
+                          <a:solidFill>
+                            <a:srgbClr val="2D3748"/>
+                          </a:solidFill>
+                          <a:latin typeface="Calibri" pitchFamily="34" charset="0"/>
+                        </a:rPr>
+                        <a:t>Necesitas acceso a un sistema o herramienta (P04)</a:t>
+                      </a:r>
+                    </a:p>
+                  </a:txBody>
+                  <a:tcPr marL="91440" marR="91440" marT="45720" marB="45720">
+                    <a:lnL w="12700">
+                      <a:solidFill>
+                        <a:srgbClr val="E2E8F0"/>
+                      </a:solidFill>
+                    </a:lnL>
+                    <a:lnR w="12700">
+                      <a:solidFill>
+                        <a:srgbClr val="E2E8F0"/>
+                      </a:solidFill>
+                    </a:lnR>
+                    <a:lnT w="12700">
+                      <a:solidFill>
+                        <a:srgbClr val="E2E8F0"/>
+                      </a:solidFill>
+                    </a:lnT>
+                    <a:lnB w="12700">
+                      <a:solidFill>
+                        <a:srgbClr val="E2E8F0"/>
+                      </a:solidFill>
+                    </a:lnB>
+                    <a:solidFill>
+                      <a:srgbClr val="F0FFF4"/>
+                    </a:solidFill>
+                  </a:tcPr>
+                </a:tc>
+                <a:tc>
+                  <a:txBody>
+                    <a:bodyPr/>
+                    <a:lstStyle/>
+                    <a:p>
+                      <a:r>
+                        <a:rPr lang="es-ES" sz="1100" dirty="0">
+                          <a:solidFill>
+                            <a:srgbClr val="2D3748"/>
+                          </a:solidFill>
+                          <a:latin typeface="Calibri" pitchFamily="34" charset="0"/>
+                        </a:rPr>
+                        <a:t>Planificar campanas de marketing</a:t>
+                      </a:r>
+                    </a:p>
+                  </a:txBody>
+                  <a:tcPr marL="91440" marR="91440" marT="45720" marB="45720">
+                    <a:lnL w="12700">
+                      <a:solidFill>
+                        <a:srgbClr val="E2E8F0"/>
+                      </a:solidFill>
+                    </a:lnL>
+                    <a:lnR w="12700">
+                      <a:solidFill>
+                        <a:srgbClr val="E2E8F0"/>
+                      </a:solidFill>
+                    </a:lnR>
+                    <a:lnT w="12700">
+                      <a:solidFill>
+                        <a:srgbClr val="E2E8F0"/>
+                      </a:solidFill>
+                    </a:lnT>
+                    <a:lnB w="12700">
+                      <a:solidFill>
+                        <a:srgbClr val="E2E8F0"/>
+                      </a:solidFill>
+                    </a:lnB>
+                    <a:solidFill>
+                      <a:srgbClr val="FFF5F5"/>
+                    </a:solidFill>
+                  </a:tcPr>
+                </a:tc>
+              </a:tr>
+              <a:tr h="365760">
+                <a:tc>
+                  <a:txBody>
+                    <a:bodyPr/>
+                    <a:lstStyle/>
+                    <a:p>
+                      <a:r>
+                        <a:rPr lang="es-ES" sz="1100" dirty="0">
+                          <a:solidFill>
+                            <a:srgbClr val="2D3748"/>
+                          </a:solidFill>
+                          <a:latin typeface="Calibri" pitchFamily="34" charset="0"/>
+                        </a:rPr>
+                        <a:t>Quieres incorporar una herramienta nueva (P03)</a:t>
+                      </a:r>
+                    </a:p>
+                  </a:txBody>
+                  <a:tcPr marL="91440" marR="91440" marT="45720" marB="45720">
+                    <a:lnL w="12700">
+                      <a:solidFill>
+                        <a:srgbClr val="E2E8F0"/>
+                      </a:solidFill>
+                    </a:lnL>
+                    <a:lnR w="12700">
+                      <a:solidFill>
+                        <a:srgbClr val="E2E8F0"/>
+                      </a:solidFill>
+                    </a:lnR>
+                    <a:lnT w="12700">
+                      <a:solidFill>
+                        <a:srgbClr val="E2E8F0"/>
+                      </a:solidFill>
+                    </a:lnT>
+                    <a:lnB w="12700">
+                      <a:solidFill>
+                        <a:srgbClr val="E2E8F0"/>
+                      </a:solidFill>
+                    </a:lnB>
+                    <a:solidFill>
+                      <a:srgbClr val="FFFFFF"/>
+                    </a:solidFill>
+                  </a:tcPr>
+                </a:tc>
+                <a:tc>
+                  <a:txBody>
+                    <a:bodyPr/>
+                    <a:lstStyle/>
+                    <a:p>
+                      <a:r>
+                        <a:rPr lang="es-ES" sz="1100" dirty="0">
+                          <a:solidFill>
+                            <a:srgbClr val="2D3748"/>
+                          </a:solidFill>
+                          <a:latin typeface="Calibri" pitchFamily="34" charset="0"/>
+                        </a:rPr>
+                        <a:t>Reuniones comerciales con clientes</a:t>
+                      </a:r>
+                    </a:p>
+                  </a:txBody>
+                  <a:tcPr marL="91440" marR="91440" marT="45720" marB="45720">
+                    <a:lnL w="12700">
+                      <a:solidFill>
+                        <a:srgbClr val="E2E8F0"/>
+                      </a:solidFill>
+                    </a:lnL>
+                    <a:lnR w="12700">
+                      <a:solidFill>
+                        <a:srgbClr val="E2E8F0"/>
+                      </a:solidFill>
+                    </a:lnR>
+                    <a:lnT w="12700">
+                      <a:solidFill>
+                        <a:srgbClr val="E2E8F0"/>
+                      </a:solidFill>
+                    </a:lnT>
+                    <a:lnB w="12700">
+                      <a:solidFill>
+                        <a:srgbClr val="E2E8F0"/>
+                      </a:solidFill>
+                    </a:lnB>
+                    <a:solidFill>
+                      <a:srgbClr val="FFFFFF"/>
+                    </a:solidFill>
+                  </a:tcPr>
+                </a:tc>
+              </a:tr>
+              <a:tr h="365760">
+                <a:tc>
+                  <a:txBody>
+                    <a:bodyPr/>
+                    <a:lstStyle/>
+                    <a:p>
+                      <a:r>
+                        <a:rPr lang="es-ES" sz="1100" dirty="0">
+                          <a:solidFill>
+                            <a:srgbClr val="2D3748"/>
+                          </a:solidFill>
+                          <a:latin typeface="Calibri" pitchFamily="34" charset="0"/>
+                        </a:rPr>
+                        <a:t>Detectas un posible incidente de seguridad (P05)</a:t>
+                      </a:r>
+                    </a:p>
+                  </a:txBody>
+                  <a:tcPr marL="91440" marR="91440" marT="45720" marB="45720">
+                    <a:lnL w="12700">
+                      <a:solidFill>
+                        <a:srgbClr val="E2E8F0"/>
+                      </a:solidFill>
+                    </a:lnL>
+                    <a:lnR w="12700">
+                      <a:solidFill>
+                        <a:srgbClr val="E2E8F0"/>
+                      </a:solidFill>
+                    </a:lnR>
+                    <a:lnT w="12700">
+                      <a:solidFill>
+                        <a:srgbClr val="E2E8F0"/>
+                      </a:solidFill>
+                    </a:lnT>
+                    <a:lnB w="12700">
+                      <a:solidFill>
+                        <a:srgbClr val="E2E8F0"/>
+                      </a:solidFill>
+                    </a:lnB>
+                    <a:solidFill>
+                      <a:srgbClr val="F0FFF4"/>
+                    </a:solidFill>
+                  </a:tcPr>
+                </a:tc>
+                <a:tc>
+                  <a:txBody>
+                    <a:bodyPr/>
+                    <a:lstStyle/>
+                    <a:p>
+                      <a:r>
+                        <a:rPr lang="es-ES" sz="1100" dirty="0">
+                          <a:solidFill>
+                            <a:srgbClr val="2D3748"/>
+                          </a:solidFill>
+                          <a:latin typeface="Calibri" pitchFamily="34" charset="0"/>
+                        </a:rPr>
+                        <a:t>Gestion de leads y oportunidades (usa CRM)</a:t>
+                      </a:r>
+                    </a:p>
+                  </a:txBody>
+                  <a:tcPr marL="91440" marR="91440" marT="45720" marB="45720">
+                    <a:lnL w="12700">
+                      <a:solidFill>
+                        <a:srgbClr val="E2E8F0"/>
+                      </a:solidFill>
+                    </a:lnL>
+                    <a:lnR w="12700">
+                      <a:solidFill>
+                        <a:srgbClr val="E2E8F0"/>
+                      </a:solidFill>
+                    </a:lnR>
+                    <a:lnT w="12700">
+                      <a:solidFill>
+                        <a:srgbClr val="E2E8F0"/>
+                      </a:solidFill>
+                    </a:lnT>
+                    <a:lnB w="12700">
+                      <a:solidFill>
+                        <a:srgbClr val="E2E8F0"/>
+                      </a:solidFill>
+                    </a:lnB>
+                    <a:solidFill>
+                      <a:srgbClr val="FFF5F5"/>
+                    </a:solidFill>
+                  </a:tcPr>
+                </a:tc>
+              </a:tr>
+              <a:tr h="365760">
+                <a:tc>
+                  <a:txBody>
+                    <a:bodyPr/>
+                    <a:lstStyle/>
+                    <a:p>
+                      <a:r>
+                        <a:rPr lang="es-ES" sz="1100" dirty="0">
+                          <a:solidFill>
+                            <a:srgbClr val="2D3748"/>
+                          </a:solidFill>
+                          <a:latin typeface="Calibri" pitchFamily="34" charset="0"/>
+                        </a:rPr>
+                        <a:t>Necesitas dar de alta/baja un usuario (P04)</a:t>
+                      </a:r>
+                    </a:p>
+                  </a:txBody>
+                  <a:tcPr marL="91440" marR="91440" marT="45720" marB="45720">
+                    <a:lnL w="12700">
+                      <a:solidFill>
+                        <a:srgbClr val="E2E8F0"/>
+                      </a:solidFill>
+                    </a:lnL>
+                    <a:lnR w="12700">
+                      <a:solidFill>
+                        <a:srgbClr val="E2E8F0"/>
+                      </a:solidFill>
+                    </a:lnR>
+                    <a:lnT w="12700">
+                      <a:solidFill>
+                        <a:srgbClr val="E2E8F0"/>
+                      </a:solidFill>
+                    </a:lnT>
+                    <a:lnB w="12700">
+                      <a:solidFill>
+                        <a:srgbClr val="E2E8F0"/>
+                      </a:solidFill>
+                    </a:lnB>
+                    <a:solidFill>
+                      <a:srgbClr val="FFFFFF"/>
+                    </a:solidFill>
+                  </a:tcPr>
+                </a:tc>
+                <a:tc>
+                  <a:txBody>
+                    <a:bodyPr/>
+                    <a:lstStyle/>
+                    <a:p>
+                      <a:r>
+                        <a:rPr lang="es-ES" sz="1100" dirty="0">
+                          <a:solidFill>
+                            <a:srgbClr val="2D3748"/>
+                          </a:solidFill>
+                          <a:latin typeface="Calibri" pitchFamily="34" charset="0"/>
+                        </a:rPr>
+                        <a:t>Crear materiales de marketing</a:t>
+                      </a:r>
+                    </a:p>
+                  </a:txBody>
+                  <a:tcPr marL="91440" marR="91440" marT="45720" marB="45720">
+                    <a:lnL w="12700">
+                      <a:solidFill>
+                        <a:srgbClr val="E2E8F0"/>
+                      </a:solidFill>
+                    </a:lnL>
+                    <a:lnR w="12700">
+                      <a:solidFill>
+                        <a:srgbClr val="E2E8F0"/>
+                      </a:solidFill>
+                    </a:lnR>
+                    <a:lnT w="12700">
+                      <a:solidFill>
+                        <a:srgbClr val="E2E8F0"/>
+                      </a:solidFill>
+                    </a:lnT>
+                    <a:lnB w="12700">
+                      <a:solidFill>
+                        <a:srgbClr val="E2E8F0"/>
+                      </a:solidFill>
+                    </a:lnB>
+                    <a:solidFill>
+                      <a:srgbClr val="FFFFFF"/>
+                    </a:solidFill>
+                  </a:tcPr>
+                </a:tc>
+              </a:tr>
+              <a:tr h="365760">
+                <a:tc>
+                  <a:txBody>
+                    <a:bodyPr/>
+                    <a:lstStyle/>
+                    <a:p>
+                      <a:r>
+                        <a:rPr lang="es-ES" sz="1100" dirty="0">
+                          <a:solidFill>
+                            <a:srgbClr val="2D3748"/>
+                          </a:solidFill>
+                          <a:latin typeface="Calibri" pitchFamily="34" charset="0"/>
+                        </a:rPr>
+                        <a:t>Solicitas un cambio en infraestructura TIC (P03)</a:t>
+                      </a:r>
+                    </a:p>
+                  </a:txBody>
+                  <a:tcPr marL="91440" marR="91440" marT="45720" marB="45720">
+                    <a:lnL w="12700">
+                      <a:solidFill>
+                        <a:srgbClr val="E2E8F0"/>
+                      </a:solidFill>
+                    </a:lnL>
+                    <a:lnR w="12700">
+                      <a:solidFill>
+                        <a:srgbClr val="E2E8F0"/>
+                      </a:solidFill>
+                    </a:lnR>
+                    <a:lnT w="12700">
+                      <a:solidFill>
+                        <a:srgbClr val="E2E8F0"/>
+                      </a:solidFill>
+                    </a:lnT>
+                    <a:lnB w="12700">
+                      <a:solidFill>
+                        <a:srgbClr val="E2E8F0"/>
+                      </a:solidFill>
+                    </a:lnB>
+                    <a:solidFill>
+                      <a:srgbClr val="F0FFF4"/>
+                    </a:solidFill>
+                  </a:tcPr>
+                </a:tc>
+                <a:tc>
+                  <a:txBody>
+                    <a:bodyPr/>
+                    <a:lstStyle/>
+                    <a:p>
+                      <a:r>
+                        <a:rPr lang="es-ES" sz="1100" dirty="0">
+                          <a:solidFill>
+                            <a:srgbClr val="2D3748"/>
+                          </a:solidFill>
+                          <a:latin typeface="Calibri" pitchFamily="34" charset="0"/>
+                        </a:rPr>
+                        <a:t>Trabajo operativo diario de tu equipo</a:t>
+                      </a:r>
+                    </a:p>
+                  </a:txBody>
+                  <a:tcPr marL="91440" marR="91440" marT="45720" marB="45720">
+                    <a:lnL w="12700">
+                      <a:solidFill>
+                        <a:srgbClr val="E2E8F0"/>
+                      </a:solidFill>
+                    </a:lnL>
+                    <a:lnR w="12700">
+                      <a:solidFill>
+                        <a:srgbClr val="E2E8F0"/>
+                      </a:solidFill>
+                    </a:lnR>
+                    <a:lnT w="12700">
+                      <a:solidFill>
+                        <a:srgbClr val="E2E8F0"/>
+                      </a:solidFill>
+                    </a:lnT>
+                    <a:lnB w="12700">
+                      <a:solidFill>
+                        <a:srgbClr val="E2E8F0"/>
+                      </a:solidFill>
+                    </a:lnB>
+                    <a:solidFill>
+                      <a:srgbClr val="FFF5F5"/>
+                    </a:solidFill>
+                  </a:tcPr>
+                </a:tc>
+              </a:tr>
+              <a:tr h="365760">
+                <a:tc>
+                  <a:txBody>
+                    <a:bodyPr/>
+                    <a:lstStyle/>
+                    <a:p>
+                      <a:r>
+                        <a:rPr lang="es-ES" sz="1100" dirty="0">
+                          <a:solidFill>
+                            <a:srgbClr val="2D3748"/>
+                          </a:solidFill>
+                          <a:latin typeface="Calibri" pitchFamily="34" charset="0"/>
+                        </a:rPr>
+                        <a:t>Un proveedor necesita acceso a sistemas</a:t>
+                      </a:r>
+                    </a:p>
+                  </a:txBody>
+                  <a:tcPr marL="91440" marR="91440" marT="45720" marB="45720">
+                    <a:lnL w="12700">
+                      <a:solidFill>
+                        <a:srgbClr val="E2E8F0"/>
+                      </a:solidFill>
+                    </a:lnL>
+                    <a:lnR w="12700">
+                      <a:solidFill>
+                        <a:srgbClr val="E2E8F0"/>
+                      </a:solidFill>
+                    </a:lnR>
+                    <a:lnT w="12700">
+                      <a:solidFill>
+                        <a:srgbClr val="E2E8F0"/>
+                      </a:solidFill>
+                    </a:lnT>
+                    <a:lnB w="12700">
+                      <a:solidFill>
+                        <a:srgbClr val="E2E8F0"/>
+                      </a:solidFill>
+                    </a:lnB>
+                    <a:solidFill>
+                      <a:srgbClr val="FFFFFF"/>
+                    </a:solidFill>
+                  </a:tcPr>
+                </a:tc>
+                <a:tc>
+                  <a:txBody>
+                    <a:bodyPr/>
+                    <a:lstStyle/>
+                    <a:p>
+                      <a:r>
+                        <a:rPr lang="es-ES" sz="1100" dirty="0">
+                          <a:solidFill>
+                            <a:srgbClr val="2D3748"/>
+                          </a:solidFill>
+                          <a:latin typeface="Calibri" pitchFamily="34" charset="0"/>
+                        </a:rPr>
+                        <a:t>Coordinacion interna de proyectos (usa Jira)</a:t>
+                      </a:r>
+                    </a:p>
+                  </a:txBody>
+                  <a:tcPr marL="91440" marR="91440" marT="45720" marB="45720">
+                    <a:lnL w="12700">
+                      <a:solidFill>
+                        <a:srgbClr val="E2E8F0"/>
+                      </a:solidFill>
+                    </a:lnL>
+                    <a:lnR w="12700">
+                      <a:solidFill>
+                        <a:srgbClr val="E2E8F0"/>
+                      </a:solidFill>
+                    </a:lnR>
+                    <a:lnT w="12700">
+                      <a:solidFill>
+                        <a:srgbClr val="E2E8F0"/>
+                      </a:solidFill>
+                    </a:lnT>
+                    <a:lnB w="12700">
+                      <a:solidFill>
+                        <a:srgbClr val="E2E8F0"/>
+                      </a:solidFill>
+                    </a:lnB>
+                    <a:solidFill>
+                      <a:srgbClr val="FFFFFF"/>
+                    </a:solidFill>
+                  </a:tcPr>
+                </a:tc>
+              </a:tr>
+            </a:tbl>
+          </a:graphicData>
+        </a:graphic>
+      </p:graphicFrame>
+      <p:sp>
+        <p:nvSpPr>
+          <p:cNvPr id="4" name="Key Message"/>
+          <p:cNvSpPr/>
+          <p:nvPr/>
+        </p:nvSpPr>
+        <p:spPr>
+          <a:xfrm>
+            <a:off x="457200" y="4114800"/>
+            <a:ext cx="8229600" cy="685800"/>
+          </a:xfrm>
+          <a:prstGeom prst="roundRect">
+            <a:avLst>
+              <a:gd name="adj" fmla="val 8000"/>
+            </a:avLst>
+          </a:prstGeom>
+          <a:solidFill>
+            <a:srgbClr val="E6F7F1"/>
+          </a:solidFill>
+          <a:ln w="12700">
+            <a:solidFill>
+              <a:srgbClr val="0D9A76"/>
+            </a:solidFill>
+          </a:ln>
+        </p:spPr>
+        <p:txBody>
+          <a:bodyPr wrap="square" lIns="137160" tIns="68580" rIns="137160" bIns="68580" rtlCol="0" anchor="ctr"/>
+          <a:lstStyle/>
+          <a:p>
+            <a:pPr algn="ctr" indent="0" marL="0">
+              <a:buNone/>
+            </a:pPr>
+            <a:r>
+              <a:rPr lang="es-ES" sz="1100" b="1" dirty="0">
+                <a:solidFill>
+                  <a:srgbClr val="0D9A76"/>
+                </a:solidFill>
+                <a:latin typeface="Calibri" pitchFamily="34" charset="0"/>
+              </a:rPr>
+              <a:t>JSM es el punto de entrada para todo lo que afecte a sistemas, accesos o seguridad.</a:t>
+            </a:r>
+          </a:p>
+          <a:p>
+            <a:pPr algn="ctr" indent="0" marL="0">
+              <a:buNone/>
+            </a:pPr>
+            <a:r>
+              <a:rPr lang="es-ES" sz="1100" dirty="0">
+                <a:solidFill>
+                  <a:srgbClr val="2D3748"/>
+                </a:solidFill>
+                <a:latin typeface="Calibri" pitchFamily="34" charset="0"/>
+              </a:rPr>
+              <a:t>Para tu trabajo operativo diario, usa las herramientas de tu equipo (Jira, CRM, etc.)</a:t>
+            </a:r>
+          </a:p>
+        </p:txBody>
+      </p:sp>
+    </p:spTree>
+  </p:cSld>
+  <p:clrMapOvr>
+    <a:masterClrMapping/>
+  </p:clrMapOvr>
+</p:sld>
+</file>
+
 <file path=ppt/slides/slide3.xml><?xml version="1.0" encoding="utf-8"?>
 <p:sld xmlns:a="http://schemas.openxmlformats.org/drawingml/2006/main" xmlns:r="http://schemas.openxmlformats.org/officeDocument/2006/relationships" xmlns:p="http://schemas.openxmlformats.org/presentationml/2006/main">
   <p:cSld name="Slide 3">

</xml_diff>